<commit_message>
Docs, deck and workbook: current state — reputation per skill, review proof, VPS hosting and backups, 857 tests
Co-Authored-By: Claude Opus 5.5 <noreply@anthropic.com>
</commit_message>
<xml_diff>
--- a/docs/deck/agentx.pptx
+++ b/docs/deck/agentx.pptx
@@ -688,7 +688,7 @@
           <a:p>
             <a:r>
               <a:rPr lang="en-US" dirty="0"/>
-              <a:t>Close on the one line. The repo links go public on 13 October, which the submission requires.</a:t>
+              <a:t>Close on the one line. All four repos are public (since 6 October) and the site is live, as the submission requires.</a:t>
             </a:r>
             <a:endParaRPr lang="en-US" dirty="0"/>
           </a:p>
@@ -2748,8 +2748,8 @@
         </p:nvSpPr>
         <p:spPr>
           <a:xfrm>
-            <a:off x="640080" y="4206240"/>
-            <a:ext cx="3520440" cy="1051560"/>
+            <a:off x="640080" y="4069080"/>
+            <a:ext cx="2514600" cy="1051560"/>
           </a:xfrm>
           <a:prstGeom prst="roundRect">
             <a:avLst>
@@ -2775,8 +2775,8 @@
         </p:nvSpPr>
         <p:spPr>
           <a:xfrm>
-            <a:off x="896112" y="4343400"/>
-            <a:ext cx="3008376" cy="274320"/>
+            <a:off x="841248" y="4187952"/>
+            <a:ext cx="2112264" cy="274320"/>
           </a:xfrm>
           <a:prstGeom prst="rect">
             <a:avLst/>
@@ -2814,8 +2814,8 @@
         </p:nvSpPr>
         <p:spPr>
           <a:xfrm>
-            <a:off x="896112" y="4626864"/>
-            <a:ext cx="3008376" cy="502920"/>
+            <a:off x="841248" y="4480560"/>
+            <a:ext cx="2112264" cy="502920"/>
           </a:xfrm>
           <a:prstGeom prst="rect">
             <a:avLst/>
@@ -2839,7 +2839,24 @@
                 <a:ea typeface="Courier New" pitchFamily="34" charset="-122"/>
                 <a:cs typeface="Courier New" pitchFamily="34" charset="-120"/>
               </a:rPr>
-              <a:t>github.com/gopaltalaviya/agentx-contracts</a:t>
+              <a:t>github.com/gopaltalaviya/</a:t>
+            </a:r>
+            <a:endParaRPr lang="en-US" sz="1050" dirty="0"/>
+          </a:p>
+          <a:p>
+            <a:pPr indent="0" marL="0">
+              <a:buNone/>
+            </a:pPr>
+            <a:r>
+              <a:rPr lang="en-US" sz="1050" dirty="0">
+                <a:solidFill>
+                  <a:srgbClr val="6EA8FF"/>
+                </a:solidFill>
+                <a:latin typeface="Courier New" pitchFamily="34" charset="0"/>
+                <a:ea typeface="Courier New" pitchFamily="34" charset="-122"/>
+                <a:cs typeface="Courier New" pitchFamily="34" charset="-120"/>
+              </a:rPr>
+              <a:t>agentx-contracts</a:t>
             </a:r>
             <a:endParaRPr lang="en-US" sz="1050" dirty="0"/>
           </a:p>
@@ -2853,8 +2870,8 @@
         </p:nvSpPr>
         <p:spPr>
           <a:xfrm>
-            <a:off x="4489704" y="4206240"/>
-            <a:ext cx="3520440" cy="1051560"/>
+            <a:off x="3429000" y="4069080"/>
+            <a:ext cx="2514600" cy="1051560"/>
           </a:xfrm>
           <a:prstGeom prst="roundRect">
             <a:avLst>
@@ -2880,8 +2897,8 @@
         </p:nvSpPr>
         <p:spPr>
           <a:xfrm>
-            <a:off x="4745736" y="4343400"/>
-            <a:ext cx="3008376" cy="274320"/>
+            <a:off x="3630168" y="4187952"/>
+            <a:ext cx="2112264" cy="274320"/>
           </a:xfrm>
           <a:prstGeom prst="rect">
             <a:avLst/>
@@ -2919,8 +2936,8 @@
         </p:nvSpPr>
         <p:spPr>
           <a:xfrm>
-            <a:off x="4745736" y="4626864"/>
-            <a:ext cx="3008376" cy="502920"/>
+            <a:off x="3630168" y="4480560"/>
+            <a:ext cx="2112264" cy="502920"/>
           </a:xfrm>
           <a:prstGeom prst="rect">
             <a:avLst/>
@@ -2944,7 +2961,24 @@
                 <a:ea typeface="Courier New" pitchFamily="34" charset="-122"/>
                 <a:cs typeface="Courier New" pitchFamily="34" charset="-120"/>
               </a:rPr>
-              <a:t>github.com/gopaltalaviya/agentx-backend</a:t>
+              <a:t>github.com/gopaltalaviya/</a:t>
+            </a:r>
+            <a:endParaRPr lang="en-US" sz="1050" dirty="0"/>
+          </a:p>
+          <a:p>
+            <a:pPr indent="0" marL="0">
+              <a:buNone/>
+            </a:pPr>
+            <a:r>
+              <a:rPr lang="en-US" sz="1050" dirty="0">
+                <a:solidFill>
+                  <a:srgbClr val="6EA8FF"/>
+                </a:solidFill>
+                <a:latin typeface="Courier New" pitchFamily="34" charset="0"/>
+                <a:ea typeface="Courier New" pitchFamily="34" charset="-122"/>
+                <a:cs typeface="Courier New" pitchFamily="34" charset="-120"/>
+              </a:rPr>
+              <a:t>agentx-backend</a:t>
             </a:r>
             <a:endParaRPr lang="en-US" sz="1050" dirty="0"/>
           </a:p>
@@ -2958,8 +2992,8 @@
         </p:nvSpPr>
         <p:spPr>
           <a:xfrm>
-            <a:off x="8339328" y="4206240"/>
-            <a:ext cx="3520440" cy="1051560"/>
+            <a:off x="6217920" y="4069080"/>
+            <a:ext cx="2514600" cy="1051560"/>
           </a:xfrm>
           <a:prstGeom prst="roundRect">
             <a:avLst>
@@ -2985,8 +3019,8 @@
         </p:nvSpPr>
         <p:spPr>
           <a:xfrm>
-            <a:off x="8595360" y="4343400"/>
-            <a:ext cx="3008376" cy="274320"/>
+            <a:off x="6419088" y="4187952"/>
+            <a:ext cx="2112264" cy="274320"/>
           </a:xfrm>
           <a:prstGeom prst="rect">
             <a:avLst/>
@@ -3024,8 +3058,8 @@
         </p:nvSpPr>
         <p:spPr>
           <a:xfrm>
-            <a:off x="8595360" y="4626864"/>
-            <a:ext cx="3008376" cy="502920"/>
+            <a:off x="6419088" y="4480560"/>
+            <a:ext cx="2112264" cy="502920"/>
           </a:xfrm>
           <a:prstGeom prst="rect">
             <a:avLst/>
@@ -3049,15 +3083,259 @@
                 <a:ea typeface="Courier New" pitchFamily="34" charset="-122"/>
                 <a:cs typeface="Courier New" pitchFamily="34" charset="-120"/>
               </a:rPr>
-              <a:t>github.com/gopaltalaviya/agentx-interface</a:t>
+              <a:t>github.com/gopaltalaviya/</a:t>
             </a:r>
             <a:endParaRPr lang="en-US" sz="1050" dirty="0"/>
           </a:p>
-        </p:txBody>
-      </p:sp>
-      <p:sp>
-        <p:nvSpPr>
-          <p:cNvPr id="14" name="Text 11"/>
+          <a:p>
+            <a:pPr indent="0" marL="0">
+              <a:buNone/>
+            </a:pPr>
+            <a:r>
+              <a:rPr lang="en-US" sz="1050" dirty="0">
+                <a:solidFill>
+                  <a:srgbClr val="6EA8FF"/>
+                </a:solidFill>
+                <a:latin typeface="Courier New" pitchFamily="34" charset="0"/>
+                <a:ea typeface="Courier New" pitchFamily="34" charset="-122"/>
+                <a:cs typeface="Courier New" pitchFamily="34" charset="-120"/>
+              </a:rPr>
+              <a:t>agentx-interface</a:t>
+            </a:r>
+            <a:endParaRPr lang="en-US" sz="1050" dirty="0"/>
+          </a:p>
+        </p:txBody>
+      </p:sp>
+      <p:sp>
+        <p:nvSpPr>
+          <p:cNvPr id="14" name="Shape 11"/>
+          <p:cNvSpPr/>
+          <p:nvPr/>
+        </p:nvSpPr>
+        <p:spPr>
+          <a:xfrm>
+            <a:off x="9006840" y="4069080"/>
+            <a:ext cx="2514600" cy="1051560"/>
+          </a:xfrm>
+          <a:prstGeom prst="roundRect">
+            <a:avLst>
+              <a:gd name="adj" fmla="val 6957"/>
+            </a:avLst>
+          </a:prstGeom>
+          <a:solidFill>
+            <a:srgbClr val="161B23"/>
+          </a:solidFill>
+          <a:ln w="12700">
+            <a:solidFill>
+              <a:srgbClr val="252C38"/>
+            </a:solidFill>
+            <a:prstDash val="solid"/>
+          </a:ln>
+        </p:spPr>
+      </p:sp>
+      <p:sp>
+        <p:nvSpPr>
+          <p:cNvPr id="15" name="Text 12"/>
+          <p:cNvSpPr txBox="1"/>
+          <p:nvPr/>
+        </p:nvSpPr>
+        <p:spPr>
+          <a:xfrm>
+            <a:off x="9208008" y="4187952"/>
+            <a:ext cx="2112264" cy="274320"/>
+          </a:xfrm>
+          <a:prstGeom prst="rect">
+            <a:avLst/>
+          </a:prstGeom>
+          <a:noFill/>
+          <a:ln/>
+        </p:spPr>
+        <p:txBody>
+          <a:bodyPr wrap="square" lIns="0" tIns="0" rIns="0" bIns="0" rtlCol="0" anchor="ctr"/>
+          <a:lstStyle/>
+          <a:p>
+            <a:pPr indent="0" marL="0">
+              <a:buNone/>
+            </a:pPr>
+            <a:r>
+              <a:rPr lang="en-US" sz="1200" dirty="0">
+                <a:solidFill>
+                  <a:srgbClr val="97A1B2"/>
+                </a:solidFill>
+                <a:latin typeface="Calibri" pitchFamily="34" charset="0"/>
+                <a:ea typeface="Calibri" pitchFamily="34" charset="-122"/>
+                <a:cs typeface="Calibri" pitchFamily="34" charset="-120"/>
+              </a:rPr>
+              <a:t>Docs, deck &amp; video</a:t>
+            </a:r>
+            <a:endParaRPr lang="en-US" sz="1200" dirty="0"/>
+          </a:p>
+        </p:txBody>
+      </p:sp>
+      <p:sp>
+        <p:nvSpPr>
+          <p:cNvPr id="16" name="Text 13"/>
+          <p:cNvSpPr txBox="1"/>
+          <p:nvPr/>
+        </p:nvSpPr>
+        <p:spPr>
+          <a:xfrm>
+            <a:off x="9208008" y="4480560"/>
+            <a:ext cx="2112264" cy="502920"/>
+          </a:xfrm>
+          <a:prstGeom prst="rect">
+            <a:avLst/>
+          </a:prstGeom>
+          <a:noFill/>
+          <a:ln/>
+        </p:spPr>
+        <p:txBody>
+          <a:bodyPr wrap="square" lIns="0" tIns="0" rIns="0" bIns="0" rtlCol="0" anchor="ctr"/>
+          <a:lstStyle/>
+          <a:p>
+            <a:pPr indent="0" marL="0">
+              <a:buNone/>
+            </a:pPr>
+            <a:r>
+              <a:rPr lang="en-US" sz="1050" dirty="0">
+                <a:solidFill>
+                  <a:srgbClr val="6EA8FF"/>
+                </a:solidFill>
+                <a:latin typeface="Courier New" pitchFamily="34" charset="0"/>
+                <a:ea typeface="Courier New" pitchFamily="34" charset="-122"/>
+                <a:cs typeface="Courier New" pitchFamily="34" charset="-120"/>
+              </a:rPr>
+              <a:t>github.com/gopaltalaviya/</a:t>
+            </a:r>
+            <a:endParaRPr lang="en-US" sz="1050" dirty="0"/>
+          </a:p>
+          <a:p>
+            <a:pPr indent="0" marL="0">
+              <a:buNone/>
+            </a:pPr>
+            <a:r>
+              <a:rPr lang="en-US" sz="1050" dirty="0">
+                <a:solidFill>
+                  <a:srgbClr val="6EA8FF"/>
+                </a:solidFill>
+                <a:latin typeface="Courier New" pitchFamily="34" charset="0"/>
+                <a:ea typeface="Courier New" pitchFamily="34" charset="-122"/>
+                <a:cs typeface="Courier New" pitchFamily="34" charset="-120"/>
+              </a:rPr>
+              <a:t>agentx-docs</a:t>
+            </a:r>
+            <a:endParaRPr lang="en-US" sz="1050" dirty="0"/>
+          </a:p>
+        </p:txBody>
+      </p:sp>
+      <p:sp>
+        <p:nvSpPr>
+          <p:cNvPr id="17" name="Shape 14"/>
+          <p:cNvSpPr/>
+          <p:nvPr/>
+        </p:nvSpPr>
+        <p:spPr>
+          <a:xfrm>
+            <a:off x="640080" y="5257800"/>
+            <a:ext cx="10881360" cy="548640"/>
+          </a:xfrm>
+          <a:prstGeom prst="roundRect">
+            <a:avLst>
+              <a:gd name="adj" fmla="val 13333"/>
+            </a:avLst>
+          </a:prstGeom>
+          <a:solidFill>
+            <a:srgbClr val="161B23"/>
+          </a:solidFill>
+          <a:ln w="12700">
+            <a:solidFill>
+              <a:srgbClr val="252C38"/>
+            </a:solidFill>
+            <a:prstDash val="solid"/>
+          </a:ln>
+        </p:spPr>
+      </p:sp>
+      <p:sp>
+        <p:nvSpPr>
+          <p:cNvPr id="18" name="Text 15"/>
+          <p:cNvSpPr txBox="1"/>
+          <p:nvPr/>
+        </p:nvSpPr>
+        <p:spPr>
+          <a:xfrm>
+            <a:off x="841248" y="5394960"/>
+            <a:ext cx="1645920" cy="274320"/>
+          </a:xfrm>
+          <a:prstGeom prst="rect">
+            <a:avLst/>
+          </a:prstGeom>
+          <a:noFill/>
+          <a:ln/>
+        </p:spPr>
+        <p:txBody>
+          <a:bodyPr wrap="square" lIns="0" tIns="0" rIns="0" bIns="0" rtlCol="0" anchor="ctr"/>
+          <a:lstStyle/>
+          <a:p>
+            <a:pPr indent="0" marL="0">
+              <a:buNone/>
+            </a:pPr>
+            <a:r>
+              <a:rPr lang="en-US" sz="1200" dirty="0">
+                <a:solidFill>
+                  <a:srgbClr val="97A1B2"/>
+                </a:solidFill>
+                <a:latin typeface="Calibri" pitchFamily="34" charset="0"/>
+                <a:ea typeface="Calibri" pitchFamily="34" charset="-122"/>
+                <a:cs typeface="Calibri" pitchFamily="34" charset="-120"/>
+              </a:rPr>
+              <a:t>Live site</a:t>
+            </a:r>
+            <a:endParaRPr lang="en-US" sz="1200" dirty="0"/>
+          </a:p>
+        </p:txBody>
+      </p:sp>
+      <p:sp>
+        <p:nvSpPr>
+          <p:cNvPr id="19" name="Text 16"/>
+          <p:cNvSpPr txBox="1"/>
+          <p:nvPr/>
+        </p:nvSpPr>
+        <p:spPr>
+          <a:xfrm>
+            <a:off x="2560320" y="5394960"/>
+            <a:ext cx="8759952" cy="274320"/>
+          </a:xfrm>
+          <a:prstGeom prst="rect">
+            <a:avLst/>
+          </a:prstGeom>
+          <a:noFill/>
+          <a:ln/>
+        </p:spPr>
+        <p:txBody>
+          <a:bodyPr wrap="square" lIns="0" tIns="0" rIns="0" bIns="0" rtlCol="0" anchor="ctr"/>
+          <a:lstStyle/>
+          <a:p>
+            <a:pPr indent="0" marL="0">
+              <a:buNone/>
+            </a:pPr>
+            <a:r>
+              <a:rPr lang="en-US" sz="1200" dirty="0">
+                <a:solidFill>
+                  <a:srgbClr val="6EA8FF"/>
+                </a:solidFill>
+                <a:latin typeface="Courier New" pitchFamily="34" charset="0"/>
+                <a:ea typeface="Courier New" pitchFamily="34" charset="-122"/>
+                <a:cs typeface="Courier New" pitchFamily="34" charset="-120"/>
+              </a:rPr>
+              <a:t>https://agentx-interface-iota.vercel.app</a:t>
+            </a:r>
+            <a:endParaRPr lang="en-US" sz="1200" dirty="0"/>
+          </a:p>
+        </p:txBody>
+      </p:sp>
+      <p:sp>
+        <p:nvSpPr>
+          <p:cNvPr id="20" name="Text 17"/>
           <p:cNvSpPr txBox="1"/>
           <p:nvPr/>
         </p:nvSpPr>
@@ -5397,7 +5675,7 @@
                 <a:ea typeface="Cambria" pitchFamily="34" charset="-122"/>
                 <a:cs typeface="Cambria" pitchFamily="34" charset="-120"/>
               </a:rPr>
-              <a:t>789</a:t>
+              <a:t>857</a:t>
             </a:r>
             <a:endParaRPr lang="en-US" sz="3600" dirty="0"/>
           </a:p>

</xml_diff>